<commit_message>
Convert Chapter 6 (Descriptive Statistics and EDA) to Python across book, playground, and slides
</commit_message>
<xml_diff>
--- a/Data2thesisBookCover.pptx
+++ b/Data2thesisBookCover.pptx
@@ -244,7 +244,7 @@
           <a:p>
             <a:fld id="{8A423862-3F52-459D-BB97-400A2FF529BA}" type="datetimeFigureOut">
               <a:rPr lang="en-US" smtClean="0"/>
-              <a:t>2026-09-30</a:t>
+              <a:t>2026-10-22</a:t>
             </a:fld>
             <a:endParaRPr lang="en-US"/>
           </a:p>
@@ -414,7 +414,7 @@
           <a:p>
             <a:fld id="{8A423862-3F52-459D-BB97-400A2FF529BA}" type="datetimeFigureOut">
               <a:rPr lang="en-US" smtClean="0"/>
-              <a:t>2026-09-30</a:t>
+              <a:t>2026-10-22</a:t>
             </a:fld>
             <a:endParaRPr lang="en-US"/>
           </a:p>
@@ -594,7 +594,7 @@
           <a:p>
             <a:fld id="{8A423862-3F52-459D-BB97-400A2FF529BA}" type="datetimeFigureOut">
               <a:rPr lang="en-US" smtClean="0"/>
-              <a:t>2026-09-30</a:t>
+              <a:t>2026-10-22</a:t>
             </a:fld>
             <a:endParaRPr lang="en-US"/>
           </a:p>
@@ -764,7 +764,7 @@
           <a:p>
             <a:fld id="{8A423862-3F52-459D-BB97-400A2FF529BA}" type="datetimeFigureOut">
               <a:rPr lang="en-US" smtClean="0"/>
-              <a:t>2026-09-30</a:t>
+              <a:t>2026-10-22</a:t>
             </a:fld>
             <a:endParaRPr lang="en-US"/>
           </a:p>
@@ -1010,7 +1010,7 @@
           <a:p>
             <a:fld id="{8A423862-3F52-459D-BB97-400A2FF529BA}" type="datetimeFigureOut">
               <a:rPr lang="en-US" smtClean="0"/>
-              <a:t>2026-09-30</a:t>
+              <a:t>2026-10-22</a:t>
             </a:fld>
             <a:endParaRPr lang="en-US"/>
           </a:p>
@@ -1242,7 +1242,7 @@
           <a:p>
             <a:fld id="{8A423862-3F52-459D-BB97-400A2FF529BA}" type="datetimeFigureOut">
               <a:rPr lang="en-US" smtClean="0"/>
-              <a:t>2026-09-30</a:t>
+              <a:t>2026-10-22</a:t>
             </a:fld>
             <a:endParaRPr lang="en-US"/>
           </a:p>
@@ -1609,7 +1609,7 @@
           <a:p>
             <a:fld id="{8A423862-3F52-459D-BB97-400A2FF529BA}" type="datetimeFigureOut">
               <a:rPr lang="en-US" smtClean="0"/>
-              <a:t>2026-09-30</a:t>
+              <a:t>2026-10-22</a:t>
             </a:fld>
             <a:endParaRPr lang="en-US"/>
           </a:p>
@@ -1727,7 +1727,7 @@
           <a:p>
             <a:fld id="{8A423862-3F52-459D-BB97-400A2FF529BA}" type="datetimeFigureOut">
               <a:rPr lang="en-US" smtClean="0"/>
-              <a:t>2026-09-30</a:t>
+              <a:t>2026-10-22</a:t>
             </a:fld>
             <a:endParaRPr lang="en-US"/>
           </a:p>
@@ -1822,7 +1822,7 @@
           <a:p>
             <a:fld id="{8A423862-3F52-459D-BB97-400A2FF529BA}" type="datetimeFigureOut">
               <a:rPr lang="en-US" smtClean="0"/>
-              <a:t>2026-09-30</a:t>
+              <a:t>2026-10-22</a:t>
             </a:fld>
             <a:endParaRPr lang="en-US"/>
           </a:p>
@@ -2099,7 +2099,7 @@
           <a:p>
             <a:fld id="{8A423862-3F52-459D-BB97-400A2FF529BA}" type="datetimeFigureOut">
               <a:rPr lang="en-US" smtClean="0"/>
-              <a:t>2026-09-30</a:t>
+              <a:t>2026-10-22</a:t>
             </a:fld>
             <a:endParaRPr lang="en-US"/>
           </a:p>
@@ -2356,7 +2356,7 @@
           <a:p>
             <a:fld id="{8A423862-3F52-459D-BB97-400A2FF529BA}" type="datetimeFigureOut">
               <a:rPr lang="en-US" smtClean="0"/>
-              <a:t>2026-09-30</a:t>
+              <a:t>2026-10-22</a:t>
             </a:fld>
             <a:endParaRPr lang="en-US"/>
           </a:p>
@@ -2569,7 +2569,7 @@
           <a:p>
             <a:fld id="{8A423862-3F52-459D-BB97-400A2FF529BA}" type="datetimeFigureOut">
               <a:rPr lang="en-US" smtClean="0"/>
-              <a:t>2026-09-30</a:t>
+              <a:t>2026-10-22</a:t>
             </a:fld>
             <a:endParaRPr lang="en-US"/>
           </a:p>
@@ -3193,45 +3193,8 @@
                 <a:ea typeface="ADLaM Display" panose="020F0502020204030204" pitchFamily="2" charset="0"/>
                 <a:cs typeface="Mongolian Baiti" panose="03000500000000000000" pitchFamily="66" charset="0"/>
               </a:rPr>
-              <a:t>Using R </a:t>
-            </a:r>
-            <a:r>
-              <a:rPr lang="en-US" sz="2000" b="1">
-                <a:ln/>
-                <a:solidFill>
-                  <a:srgbClr val="1E272E"/>
-                </a:solidFill>
-                <a:effectLst>
-                  <a:outerShdw blurRad="38100" dist="19050" dir="2700000" algn="tl" rotWithShape="0">
-                    <a:schemeClr val="dk1">
-                      <a:lumMod val="50000"/>
-                      <a:alpha val="40000"/>
-                    </a:schemeClr>
-                  </a:outerShdw>
-                </a:effectLst>
-                <a:latin typeface="Mongolian Baiti" panose="03000500000000000000" pitchFamily="66" charset="0"/>
-                <a:ea typeface="ADLaM Display" panose="020F0502020204030204" pitchFamily="2" charset="0"/>
-                <a:cs typeface="Mongolian Baiti" panose="03000500000000000000" pitchFamily="66" charset="0"/>
-              </a:rPr>
-              <a:t>for Non-Technical</a:t>
-            </a:r>
-            <a:endParaRPr lang="en-US" sz="2000" b="1" dirty="0">
-              <a:ln/>
-              <a:solidFill>
-                <a:srgbClr val="1E272E"/>
-              </a:solidFill>
-              <a:effectLst>
-                <a:outerShdw blurRad="38100" dist="19050" dir="2700000" algn="tl" rotWithShape="0">
-                  <a:schemeClr val="dk1">
-                    <a:lumMod val="50000"/>
-                    <a:alpha val="40000"/>
-                  </a:schemeClr>
-                </a:outerShdw>
-              </a:effectLst>
-              <a:latin typeface="Mongolian Baiti" panose="03000500000000000000" pitchFamily="66" charset="0"/>
-              <a:ea typeface="ADLaM Display" panose="020F0502020204030204" pitchFamily="2" charset="0"/>
-              <a:cs typeface="Mongolian Baiti" panose="03000500000000000000" pitchFamily="66" charset="0"/>
-            </a:endParaRPr>
+              <a:t>Using Python for Non-Technical</a:t>
+            </a:r>
           </a:p>
         </p:txBody>
       </p:sp>
@@ -3448,82 +3411,11 @@
                 <a:latin typeface="Bookman Old Style" panose="02050604050505020204" pitchFamily="18" charset="0"/>
                 <a:cs typeface="Posterama" panose="020B0504020200020000" pitchFamily="34" charset="0"/>
               </a:rPr>
-              <a:t>by Polla Fattah</a:t>
-            </a:r>
-          </a:p>
-          <a:p>
-            <a:pPr lvl="0" algn="ctr"/>
-            <a:r>
-              <a:rPr lang="en-US" sz="2000" dirty="0">
-                <a:gradFill flip="none" rotWithShape="1">
-                  <a:gsLst>
-                    <a:gs pos="0">
-                      <a:schemeClr val="lt1">
-                        <a:shade val="30000"/>
-                        <a:satMod val="115000"/>
-                      </a:schemeClr>
-                    </a:gs>
-                    <a:gs pos="50000">
-                      <a:schemeClr val="lt1">
-                        <a:shade val="67500"/>
-                        <a:satMod val="115000"/>
-                      </a:schemeClr>
-                    </a:gs>
-                    <a:gs pos="100000">
-                      <a:schemeClr val="lt1">
-                        <a:shade val="100000"/>
-                        <a:satMod val="115000"/>
-                      </a:schemeClr>
-                    </a:gs>
-                  </a:gsLst>
-                  <a:lin ang="8100000" scaled="1"/>
-                  <a:tileRect/>
-                </a:gradFill>
-                <a:effectLst>
-                  <a:innerShdw blurRad="63500" dist="50800" dir="16200000">
-                    <a:prstClr val="black">
-                      <a:alpha val="50000"/>
-                    </a:prstClr>
-                  </a:innerShdw>
-                </a:effectLst>
-                <a:latin typeface="Bookman Old Style" panose="02050604050505020204" pitchFamily="18" charset="0"/>
-                <a:cs typeface="Posterama" panose="020B0504020200020000" pitchFamily="34" charset="0"/>
-              </a:rPr>
-              <a:t>and Collection of LLMs</a:t>
-            </a:r>
-          </a:p>
-        </p:txBody>
-      </p:sp>
-      <p:pic>
-        <p:nvPicPr>
-          <p:cNvPr id="17" name="Picture 16">
-            <a:extLst>
-              <a:ext uri="{FF2B5EF4-FFF2-40B4-BE49-F238E27FC236}">
-                <a16:creationId xmlns:a16="http://schemas.microsoft.com/office/drawing/2014/main" id="{A76AEF4D-7D39-82F0-67DD-07495FC2D166}"/>
-              </a:ext>
-            </a:extLst>
-          </p:cNvPr>
-          <p:cNvPicPr>
-            <a:picLocks noChangeAspect="1"/>
-          </p:cNvPicPr>
-          <p:nvPr/>
-        </p:nvPicPr>
-        <p:blipFill>
-          <a:blip r:embed="rId4"/>
-          <a:stretch>
-            <a:fillRect/>
-          </a:stretch>
-        </p:blipFill>
-        <p:spPr>
-          <a:xfrm>
-            <a:off x="1458636" y="2383997"/>
-            <a:ext cx="3882004" cy="4850776"/>
-          </a:xfrm>
-          <a:prstGeom prst="rect">
-            <a:avLst/>
-          </a:prstGeom>
-        </p:spPr>
-      </p:pic>
+              <a:t>by Polla Fattah and an Ensemble of LLMs</a:t>
+            </a:r>
+          </a:p>
+        </p:txBody>
+      </p:sp>
       <p:sp>
         <p:nvSpPr>
           <p:cNvPr id="19" name="Rectangle 18">
@@ -3614,6 +3506,37 @@
           </a:p>
         </p:txBody>
       </p:sp>
+      <p:pic>
+        <p:nvPicPr>
+          <p:cNvPr id="2" name="Picture 1">
+            <a:extLst>
+              <a:ext uri="{FF2B5EF4-FFF2-40B4-BE49-F238E27FC236}">
+                <a16:creationId xmlns:a16="http://schemas.microsoft.com/office/drawing/2014/main" id="{2F87E2E5-D3DD-4634-C096-D6F02979F29A}"/>
+              </a:ext>
+            </a:extLst>
+          </p:cNvPr>
+          <p:cNvPicPr>
+            <a:picLocks noChangeAspect="1"/>
+          </p:cNvPicPr>
+          <p:nvPr/>
+        </p:nvPicPr>
+        <p:blipFill>
+          <a:blip r:embed="rId4"/>
+          <a:srcRect l="18275"/>
+          <a:stretch>
+            <a:fillRect/>
+          </a:stretch>
+        </p:blipFill>
+        <p:spPr>
+          <a:xfrm rot="21163619">
+            <a:off x="542581" y="2804149"/>
+            <a:ext cx="5824340" cy="4192862"/>
+          </a:xfrm>
+          <a:prstGeom prst="rect">
+            <a:avLst/>
+          </a:prstGeom>
+        </p:spPr>
+      </p:pic>
     </p:spTree>
     <p:extLst>
       <p:ext uri="{BB962C8B-B14F-4D97-AF65-F5344CB8AC3E}">
@@ -3887,7 +3810,7 @@
                 <a:ea typeface="Yu Mincho Light" panose="02020300000000000000" pitchFamily="18" charset="-128"/>
                 <a:cs typeface="Mongolian Baiti" panose="03000500000000000000" pitchFamily="66" charset="0"/>
               </a:rPr>
-              <a:t>From Data To Thesis Using R</a:t>
+              <a:t>From Data To Thesis Using Python</a:t>
             </a:r>
           </a:p>
         </p:txBody>
@@ -3988,7 +3911,7 @@
                 <a:effectLst/>
                 <a:latin typeface="+mn-lt"/>
               </a:rPr>
-              <a:t>R</a:t>
+              <a:t>Python</a:t>
             </a:r>
             <a:r>
               <a:rPr lang="en-US" sz="1200" b="0" i="0" dirty="0">
@@ -4196,7 +4119,7 @@
             </a:endParaRPr>
           </a:p>
           <a:p>
-            <a:pPr marL="342900" lvl="0" indent="-342900" algn="l">
+            <a:pPr marL="342900" lvl="0" indent="-342900">
               <a:buFont typeface="Wingdings" panose="05000000000000000000" pitchFamily="2" charset="2"/>
               <a:buChar char="v"/>
             </a:pPr>
@@ -4208,27 +4131,7 @@
                 <a:effectLst/>
                 <a:latin typeface="+mn-lt"/>
               </a:rPr>
-              <a:t>How to clean, reshape, and visualize complex data using modern </a:t>
-            </a:r>
-            <a:r>
-              <a:rPr lang="en-US" sz="1200" b="1" i="0" dirty="0" err="1">
-                <a:solidFill>
-                  <a:schemeClr val="bg1"/>
-                </a:solidFill>
-                <a:effectLst/>
-                <a:latin typeface="+mn-lt"/>
-              </a:rPr>
-              <a:t>tidyverse</a:t>
-            </a:r>
-            <a:r>
-              <a:rPr lang="en-US" sz="1200" b="0" i="0" dirty="0">
-                <a:solidFill>
-                  <a:schemeClr val="bg1"/>
-                </a:solidFill>
-                <a:effectLst/>
-                <a:latin typeface="+mn-lt"/>
-              </a:rPr>
-              <a:t> workflows.</a:t>
+              <a:t>How to clean, reshape, and visualize complex data using modern workflows.</a:t>
             </a:r>
           </a:p>
           <a:p>
@@ -4264,7 +4167,7 @@
             </a:r>
           </a:p>
           <a:p>
-            <a:pPr marL="342900" lvl="0" indent="-342900" algn="l">
+            <a:pPr marL="342900" lvl="0" indent="-342900">
               <a:buFont typeface="Wingdings" panose="05000000000000000000" pitchFamily="2" charset="2"/>
               <a:buChar char="v"/>
             </a:pPr>
@@ -4279,14 +4182,12 @@
               <a:t>Reproducible research workflows using </a:t>
             </a:r>
             <a:r>
-              <a:rPr lang="en-US" sz="1200" b="1" i="0" dirty="0">
+              <a:rPr lang="en-US" sz="1200" b="1" dirty="0">
                 <a:solidFill>
                   <a:schemeClr val="bg1"/>
                 </a:solidFill>
-                <a:effectLst/>
-                <a:latin typeface="+mn-lt"/>
               </a:rPr>
-              <a:t>Quarto</a:t>
+              <a:t>Quarto and Jupyter</a:t>
             </a:r>
             <a:r>
               <a:rPr lang="en-US" sz="1200" b="0" i="0" dirty="0">

</xml_diff>

<commit_message>
refactor: purge all legacy R files, convert Appendices A-D to Python, and update freeze cache to Jupyter
</commit_message>
<xml_diff>
--- a/Data2thesisBookCover.pptx
+++ b/Data2thesisBookCover.pptx
@@ -244,7 +244,7 @@
           <a:p>
             <a:fld id="{8A423862-3F52-459D-BB97-400A2FF529BA}" type="datetimeFigureOut">
               <a:rPr lang="en-US" smtClean="0"/>
-              <a:t>2026-10-22</a:t>
+              <a:t>2026-10-23</a:t>
             </a:fld>
             <a:endParaRPr lang="en-US"/>
           </a:p>
@@ -414,7 +414,7 @@
           <a:p>
             <a:fld id="{8A423862-3F52-459D-BB97-400A2FF529BA}" type="datetimeFigureOut">
               <a:rPr lang="en-US" smtClean="0"/>
-              <a:t>2026-10-22</a:t>
+              <a:t>2026-10-23</a:t>
             </a:fld>
             <a:endParaRPr lang="en-US"/>
           </a:p>
@@ -594,7 +594,7 @@
           <a:p>
             <a:fld id="{8A423862-3F52-459D-BB97-400A2FF529BA}" type="datetimeFigureOut">
               <a:rPr lang="en-US" smtClean="0"/>
-              <a:t>2026-10-22</a:t>
+              <a:t>2026-10-23</a:t>
             </a:fld>
             <a:endParaRPr lang="en-US"/>
           </a:p>
@@ -764,7 +764,7 @@
           <a:p>
             <a:fld id="{8A423862-3F52-459D-BB97-400A2FF529BA}" type="datetimeFigureOut">
               <a:rPr lang="en-US" smtClean="0"/>
-              <a:t>2026-10-22</a:t>
+              <a:t>2026-10-23</a:t>
             </a:fld>
             <a:endParaRPr lang="en-US"/>
           </a:p>
@@ -1010,7 +1010,7 @@
           <a:p>
             <a:fld id="{8A423862-3F52-459D-BB97-400A2FF529BA}" type="datetimeFigureOut">
               <a:rPr lang="en-US" smtClean="0"/>
-              <a:t>2026-10-22</a:t>
+              <a:t>2026-10-23</a:t>
             </a:fld>
             <a:endParaRPr lang="en-US"/>
           </a:p>
@@ -1242,7 +1242,7 @@
           <a:p>
             <a:fld id="{8A423862-3F52-459D-BB97-400A2FF529BA}" type="datetimeFigureOut">
               <a:rPr lang="en-US" smtClean="0"/>
-              <a:t>2026-10-22</a:t>
+              <a:t>2026-10-23</a:t>
             </a:fld>
             <a:endParaRPr lang="en-US"/>
           </a:p>
@@ -1609,7 +1609,7 @@
           <a:p>
             <a:fld id="{8A423862-3F52-459D-BB97-400A2FF529BA}" type="datetimeFigureOut">
               <a:rPr lang="en-US" smtClean="0"/>
-              <a:t>2026-10-22</a:t>
+              <a:t>2026-10-23</a:t>
             </a:fld>
             <a:endParaRPr lang="en-US"/>
           </a:p>
@@ -1727,7 +1727,7 @@
           <a:p>
             <a:fld id="{8A423862-3F52-459D-BB97-400A2FF529BA}" type="datetimeFigureOut">
               <a:rPr lang="en-US" smtClean="0"/>
-              <a:t>2026-10-22</a:t>
+              <a:t>2026-10-23</a:t>
             </a:fld>
             <a:endParaRPr lang="en-US"/>
           </a:p>
@@ -1822,7 +1822,7 @@
           <a:p>
             <a:fld id="{8A423862-3F52-459D-BB97-400A2FF529BA}" type="datetimeFigureOut">
               <a:rPr lang="en-US" smtClean="0"/>
-              <a:t>2026-10-22</a:t>
+              <a:t>2026-10-23</a:t>
             </a:fld>
             <a:endParaRPr lang="en-US"/>
           </a:p>
@@ -2099,7 +2099,7 @@
           <a:p>
             <a:fld id="{8A423862-3F52-459D-BB97-400A2FF529BA}" type="datetimeFigureOut">
               <a:rPr lang="en-US" smtClean="0"/>
-              <a:t>2026-10-22</a:t>
+              <a:t>2026-10-23</a:t>
             </a:fld>
             <a:endParaRPr lang="en-US"/>
           </a:p>
@@ -2356,7 +2356,7 @@
           <a:p>
             <a:fld id="{8A423862-3F52-459D-BB97-400A2FF529BA}" type="datetimeFigureOut">
               <a:rPr lang="en-US" smtClean="0"/>
-              <a:t>2026-10-22</a:t>
+              <a:t>2026-10-23</a:t>
             </a:fld>
             <a:endParaRPr lang="en-US"/>
           </a:p>
@@ -2569,7 +2569,7 @@
           <a:p>
             <a:fld id="{8A423862-3F52-459D-BB97-400A2FF529BA}" type="datetimeFigureOut">
               <a:rPr lang="en-US" smtClean="0"/>
-              <a:t>2026-10-22</a:t>
+              <a:t>2026-10-23</a:t>
             </a:fld>
             <a:endParaRPr lang="en-US"/>
           </a:p>
@@ -2990,6 +2990,7 @@
         </p:nvPicPr>
         <p:blipFill>
           <a:blip r:embed="rId2"/>
+          <a:srcRect b="14909"/>
           <a:stretch>
             <a:fillRect/>
           </a:stretch>
@@ -2997,7 +2998,7 @@
         <p:spPr>
           <a:xfrm>
             <a:off x="0" y="-50334"/>
-            <a:ext cx="6858000" cy="9179859"/>
+            <a:ext cx="6858000" cy="9422934"/>
           </a:xfrm>
           <a:prstGeom prst="rect">
             <a:avLst/>
@@ -3583,14 +3584,15 @@
         </p:nvPicPr>
         <p:blipFill>
           <a:blip r:embed="rId2"/>
+          <a:srcRect b="14454"/>
           <a:stretch>
             <a:fillRect/>
           </a:stretch>
         </p:blipFill>
         <p:spPr>
           <a:xfrm>
-            <a:off x="0" y="-50334"/>
-            <a:ext cx="6858000" cy="9179859"/>
+            <a:off x="0" y="-49023"/>
+            <a:ext cx="6858000" cy="9320023"/>
           </a:xfrm>
           <a:prstGeom prst="rect">
             <a:avLst/>

</xml_diff>